<commit_message>
Deploy site from source@b3089a2
</commit_message>
<xml_diff>
--- a/projects/02-opticheskie-pribory/source/presentation.pptx
+++ b/projects/02-opticheskie-pribory/source/presentation.pptx
@@ -4464,7 +4464,7 @@
                 <a:latin typeface="Calibri"/>
                 <a:ea typeface="Calibri"/>
               </a:rPr>
-              <a:t>— система линз в передней части светонепроницаемого корпуса.</a:t>
+              <a:t>– система линз в передней части светонепроницаемого корпуса.</a:t>
             </a:r>
             <a:endParaRPr lang="ru-RU" sz="1200" b="0" u="none" strike="noStrike">
               <a:solidFill>
@@ -4542,7 +4542,7 @@
                 <a:latin typeface="Calibri"/>
                 <a:ea typeface="Calibri"/>
               </a:rPr>
-              <a:t>(плёнка или цифровая матрица) — в задней части.</a:t>
+              <a:t>(плёнка или цифровая матрица) – в задней части.</a:t>
             </a:r>
             <a:endParaRPr lang="ru-RU" sz="1200" b="0" u="none" strike="noStrike">
               <a:solidFill>
@@ -4608,7 +4608,7 @@
                 <a:latin typeface="Calibri"/>
                 <a:ea typeface="Calibri"/>
               </a:rPr>
-              <a:t>Между ними — затвор и диафрагма.</a:t>
+              <a:t>Между ними – затвор и диафрагма.</a:t>
             </a:r>
             <a:endParaRPr lang="ru-RU" sz="1200" b="0" u="none" strike="noStrike">
               <a:solidFill>
@@ -6375,7 +6375,7 @@
                 <a:latin typeface="Georgia"/>
                 <a:ea typeface="Georgia"/>
               </a:rPr>
-              <a:t>Фотоаппарат и проектор — обратные задачи</a:t>
+              <a:t>Фотоаппарат и проектор – обратные задачи</a:t>
             </a:r>
             <a:endParaRPr lang="ru-RU" sz="1400" b="0" u="none" strike="noStrike">
               <a:solidFill>
@@ -11225,7 +11225,7 @@
                 <a:latin typeface="Calibri"/>
                 <a:ea typeface="Calibri"/>
               </a:rPr>
-              <a:t>Лупа (1 линза) — </a:t>
+              <a:t>Лупа (1 линза) – </a:t>
             </a:r>
             <a:r>
               <a:rPr lang="en-US" sz="1100" b="0" u="none" strike="noStrike">
@@ -11273,7 +11273,7 @@
                 <a:latin typeface="Calibri"/>
                 <a:ea typeface="Calibri"/>
               </a:rPr>
-              <a:t>линзы) — </a:t>
+              <a:t>линзы) – </a:t>
             </a:r>
             <a:r>
               <a:rPr lang="en-US" sz="1100" b="0" u="none" strike="noStrike">
@@ -11472,7 +11472,7 @@
                 <a:latin typeface="Georgia"/>
                 <a:ea typeface="Georgia"/>
               </a:rPr>
-              <a:t>Микроскоп и телескоп: одинаковая схема — разные задачи</a:t>
+              <a:t>Микроскоп и телескоп: одинаковая схема – разные задачи</a:t>
             </a:r>
             <a:endParaRPr lang="ru-RU" sz="1200" b="0" u="none" strike="noStrike">
               <a:solidFill>
@@ -11925,7 +11925,7 @@
                 <a:latin typeface="Calibri"/>
                 <a:ea typeface="Calibri"/>
               </a:rPr>
-              <a:t>Визуальные формируют мнимое изображение (для глаза). Проекционные — действительное (на матрице/экране). Это определяет: предмет должен быть за фокусом.</a:t>
+              <a:t>Визуальные формируют мнимое изображение (для глаза). Проекционные – действительное (на матрице/экране). Это определяет: предмет должен быть за фокусом.</a:t>
             </a:r>
             <a:endParaRPr lang="ru-RU" sz="1100" b="0" u="none" strike="noStrike">
               <a:solidFill>
@@ -12769,7 +12769,7 @@
                 <a:latin typeface="Calibri"/>
                 <a:ea typeface="Calibri"/>
               </a:rPr>
-              <a:t>характеристики оптического прибора — тип изображения, увеличение, конструктивная сложность — определяются его назначением. Приборы, решающие различные задачи, различаются не случайно, а закономерно.</a:t>
+              <a:t>характеристики оптического прибора – тип изображения, увеличение, конструктивная сложность – определяются его назначением. Приборы, решающие различные задачи, различаются не случайно, а закономерно.</a:t>
             </a:r>
             <a:endParaRPr lang="ru-RU" sz="1300" b="0" u="none" strike="noStrike">
               <a:solidFill>
@@ -14075,7 +14075,7 @@
                 <a:latin typeface="Calibri"/>
                 <a:ea typeface="Calibri"/>
               </a:rPr>
-              <a:t>организаций — </a:t>
+              <a:t>организаций – </a:t>
             </a:r>
             <a:r>
               <a:rPr lang="en-US" sz="1200" b="0" u="none" strike="noStrike">
@@ -14215,7 +14215,7 @@
                 <a:latin typeface="Calibri"/>
                 <a:ea typeface="Calibri"/>
               </a:rPr>
-              <a:t>2. Савельев И.В. Курс общей физики: в 3 т. Т. 2. Электричество и магнетизм. Волны. Оптика — СПб.: Лань, 2019.</a:t>
+              <a:t>2. Савельев И.В. Курс общей физики: в 3 т. Т. 2. Электричество и магнетизм. Волны. Оптика – СПб.: Лань, 2019.</a:t>
             </a:r>
             <a:endParaRPr lang="ru-RU" sz="1200" b="0" u="none" strike="noStrike">
               <a:solidFill>
@@ -14355,7 +14355,7 @@
                 <a:latin typeface="Calibri"/>
                 <a:ea typeface="Calibri"/>
               </a:rPr>
-              <a:t>Оптика — </a:t>
+              <a:t>Оптика – </a:t>
             </a:r>
             <a:r>
               <a:rPr lang="en-US" sz="1200" b="0" u="none" strike="noStrike">
@@ -14507,7 +14507,7 @@
                 <a:latin typeface="Calibri"/>
                 <a:ea typeface="Calibri"/>
               </a:rPr>
-              <a:t>4. Сивухин Д.В. Общий курс физики: в 5 т. Т. 4. Оптика — М.: ФИЗМАТЛИТ, 2005.</a:t>
+              <a:t>4. Сивухин Д.В. Общий курс физики: в 5 т. Т. 4. Оптика – М.: ФИЗМАТЛИТ, 2005.</a:t>
             </a:r>
             <a:endParaRPr lang="ru-RU" sz="1200" b="0" u="none" strike="noStrike">
               <a:solidFill>
@@ -14611,7 +14611,7 @@
                 <a:latin typeface="Calibri"/>
                 <a:ea typeface="Calibri"/>
               </a:rPr>
-              <a:t>5. Трофимова Т.И. Курс физики — М.: Академия, 2006.</a:t>
+              <a:t>5. Трофимова Т.И. Курс физики – М.: Академия, 2006.</a:t>
             </a:r>
             <a:endParaRPr lang="ru-RU" sz="1200" b="0" u="none" strike="noStrike">
               <a:solidFill>
@@ -15388,7 +15388,7 @@
                 <a:latin typeface="Calibri"/>
                 <a:ea typeface="Calibri"/>
               </a:rPr>
-              <a:t>Оптические приборы — неотъемлемая часть науки и техники. Микроскопы позволяют исследовать клеточные структуры, телескопы — наблюдать удалённые космические объекты, фотоаппараты — фиксировать изображения. При этом все эти приборы работают на одних и тех же физических принципах: преломлении и отражении света в линзах и зеркалах.</a:t>
+              <a:t>Оптические приборы – неотъемлемая часть науки и техники. Микроскопы позволяют исследовать клеточные структуры, телескопы – наблюдать удалённые космические объекты, фотоаппараты – фиксировать изображения. При этом все эти приборы работают на одних и тех же физических принципах: преломлении и отражении света в линзах и зеркалах.</a:t>
             </a:r>
             <a:endParaRPr lang="ru-RU" sz="1400" b="0" u="none" strike="noStrike">
               <a:solidFill>
@@ -16621,7 +16621,7 @@
                 <a:latin typeface="Calibri"/>
                 <a:ea typeface="Calibri"/>
               </a:rPr>
-              <a:t>В однородной, прозрачной и изотропной среде свет распространяется прямолинейно. Это позволяет описывать свет в виде лучей — прямых линий.</a:t>
+              <a:t>В однородной, прозрачной и изотропной среде свет распространяется прямолинейно. Это позволяет описывать свет в виде лучей – прямых линий.</a:t>
             </a:r>
             <a:endParaRPr lang="ru-RU" sz="1200" b="0" u="none" strike="noStrike">
               <a:solidFill>
@@ -18734,7 +18734,7 @@
                 <a:latin typeface="Calibri"/>
                 <a:ea typeface="Calibri"/>
               </a:rPr>
-              <a:t>• f &gt; 0 — действительное изображение;  f &lt; 0 — мнимое изображение</a:t>
+              <a:t>• f &gt; 0 – действительное изображение;  f &lt; 0 – мнимое изображение</a:t>
             </a:r>
             <a:endParaRPr lang="ru-RU" sz="1200" b="0" u="none" strike="noStrike">
               <a:solidFill>
@@ -18764,7 +18764,7 @@
                 <a:latin typeface="Calibri"/>
                 <a:ea typeface="Calibri"/>
               </a:rPr>
-              <a:t>• F &gt; 0 — собирающая линза;  F &lt; 0 — рассеивающая линза</a:t>
+              <a:t>• F &gt; 0 – собирающая линза;  F &lt; 0 – рассеивающая линза</a:t>
             </a:r>
             <a:endParaRPr lang="ru-RU" sz="1200" b="0" u="none" strike="noStrike">
               <a:solidFill>
@@ -18794,7 +18794,7 @@
                 <a:latin typeface="Calibri"/>
                 <a:ea typeface="Calibri"/>
               </a:rPr>
-              <a:t>• d — расстояние от предмета до линзы (всегда положительно)</a:t>
+              <a:t>• d – расстояние от предмета до линзы (всегда положительно)</a:t>
             </a:r>
             <a:endParaRPr lang="ru-RU" sz="1200" b="0" u="none" strike="noStrike">
               <a:solidFill>
@@ -18824,7 +18824,7 @@
                 <a:latin typeface="Calibri"/>
                 <a:ea typeface="Calibri"/>
               </a:rPr>
-              <a:t>• Изображение может быть: действительным/мнимым, прямым/перевёрнутым, увеличенным/уменьшенным — в зависимости от положения предмета относительно линзы</a:t>
+              <a:t>• Изображение может быть: действительным/мнимым, прямым/перевёрнутым, увеличенным/уменьшенным – в зависимости от положения предмета относительно линзы</a:t>
             </a:r>
             <a:endParaRPr lang="ru-RU" sz="1200" b="0" u="none" strike="noStrike">
               <a:solidFill>
@@ -19753,7 +19753,7 @@
                 <a:latin typeface="Calibri"/>
                 <a:ea typeface="Calibri"/>
               </a:rPr>
-              <a:t>Изображение может быть мнимым — оно воспринимается непосредственно глазом.</a:t>
+              <a:t>Изображение может быть мнимым – оно воспринимается непосредственно глазом.</a:t>
             </a:r>
             <a:endParaRPr lang="ru-RU" sz="1300" b="0" u="none" strike="noStrike">
               <a:solidFill>
@@ -20127,7 +20127,7 @@
                 <a:latin typeface="Calibri"/>
                 <a:ea typeface="Calibri"/>
               </a:rPr>
-              <a:t>Изображение существует объективно — можно зафиксировать на плёнке, матрице или экране.</a:t>
+              <a:t>Изображение существует объективно – можно зафиксировать на плёнке, матрице или экране.</a:t>
             </a:r>
             <a:endParaRPr lang="ru-RU" sz="1300" b="0" u="none" strike="noStrike">
               <a:solidFill>
@@ -22339,7 +22339,7 @@
                 <a:latin typeface="Calibri"/>
                 <a:ea typeface="Calibri"/>
               </a:rPr>
-              <a:t>— короткофокусная линза вблизи объекта. Создаёт действительное, перевёрнутое, увеличенное промежуточное изображение (F_об &lt; d &lt; 2F_об).</a:t>
+              <a:t>– короткофокусная линза вблизи объекта. Создаёт действительное, перевёрнутое, увеличенное промежуточное изображение (F_об &lt; d &lt; 2F_об).</a:t>
             </a:r>
             <a:endParaRPr lang="ru-RU" sz="1200" b="0" u="none" strike="noStrike">
               <a:solidFill>
@@ -22417,7 +22417,7 @@
                 <a:latin typeface="Calibri"/>
                 <a:ea typeface="Calibri"/>
               </a:rPr>
-              <a:t>— линза с бо́льшим фокусным расстоянием. Работает как лупа: создаёт мнимое, увеличенное изображение промежуточного.</a:t>
+              <a:t>– линза с бо́льшим фокусным расстоянием. Работает как лупа: создаёт мнимое, увеличенное изображение промежуточного.</a:t>
             </a:r>
             <a:endParaRPr lang="ru-RU" sz="1200" b="0" u="none" strike="noStrike">
               <a:solidFill>

</xml_diff>